<commit_message>
Shorten and style decision summary; add HTML version
Co-Authored-By: Claude Sonnet 5.5 <noreply@anthropic.com>
</commit_message>
<xml_diff>
--- a/submission/04-three-slide-summary.pptx
+++ b/submission/04-three-slide-summary.pptx
@@ -3083,6 +3083,14 @@
 <file path=ppt/slides/slide1.xml><?xml version="1.0" encoding="utf-8"?>
 <p:sld xmlns:a="http://schemas.openxmlformats.org/drawingml/2006/main" xmlns:p="http://schemas.openxmlformats.org/presentationml/2006/main" xmlns:r="http://schemas.openxmlformats.org/officeDocument/2006/relationships">
   <p:cSld>
+    <p:bg>
+      <p:bgPr>
+        <a:solidFill>
+          <a:srgbClr val="F5F9FD"/>
+        </a:solidFill>
+        <a:effectLst/>
+      </p:bgPr>
+    </p:bg>
     <p:spTree>
       <p:nvGrpSpPr>
         <p:cNvPr id="1" name=""/>
@@ -3092,38 +3100,254 @@
       <p:grpSpPr/>
       <p:sp>
         <p:nvSpPr>
-          <p:cNvPr id="2" name="Title 1"/>
-          <p:cNvSpPr>
-            <a:spLocks noGrp="1"/>
-          </p:cNvSpPr>
-          <p:nvPr>
-            <p:ph type="title"/>
-          </p:nvPr>
-        </p:nvSpPr>
-        <p:spPr/>
-        <p:txBody>
-          <a:bodyPr/>
-          <a:lstStyle/>
-          <a:p>
-            <a:pPr>
-              <a:defRPr sz="3600"/>
-            </a:pPr>
-            <a:r>
-              <a:t>1. What Is Broken</a:t>
-            </a:r>
-          </a:p>
-        </p:txBody>
-      </p:sp>
-      <p:sp>
-        <p:nvSpPr>
-          <p:cNvPr id="3" name="TextBox 2"/>
+          <p:cNvPr id="2" name="Rectangle 1"/>
+          <p:cNvSpPr/>
+          <p:nvPr/>
+        </p:nvSpPr>
+        <p:spPr>
+          <a:xfrm>
+            <a:off x="0" y="0"/>
+            <a:ext cx="12188952" cy="1371600"/>
+          </a:xfrm>
+          <a:prstGeom prst="rect">
+            <a:avLst/>
+          </a:prstGeom>
+          <a:solidFill>
+            <a:srgbClr val="172033"/>
+          </a:solidFill>
+          <a:ln>
+            <a:noFill/>
+          </a:ln>
+        </p:spPr>
+        <p:style>
+          <a:lnRef idx="1">
+            <a:schemeClr val="accent1"/>
+          </a:lnRef>
+          <a:fillRef idx="3">
+            <a:schemeClr val="accent1"/>
+          </a:fillRef>
+          <a:effectRef idx="2">
+            <a:schemeClr val="accent1"/>
+          </a:effectRef>
+          <a:fontRef idx="minor">
+            <a:schemeClr val="lt1"/>
+          </a:fontRef>
+        </p:style>
+        <p:txBody>
+          <a:bodyPr rtlCol="0" anchor="ctr"/>
+          <a:lstStyle/>
+          <a:p>
+            <a:pPr algn="ctr"/>
+          </a:p>
+        </p:txBody>
+      </p:sp>
+      <p:sp>
+        <p:nvSpPr>
+          <p:cNvPr id="3" name="Rectangle 2"/>
+          <p:cNvSpPr/>
+          <p:nvPr/>
+        </p:nvSpPr>
+        <p:spPr>
+          <a:xfrm>
+            <a:off x="0" y="1371600"/>
+            <a:ext cx="12188952" cy="73152"/>
+          </a:xfrm>
+          <a:prstGeom prst="rect">
+            <a:avLst/>
+          </a:prstGeom>
+          <a:solidFill>
+            <a:srgbClr val="4677A8"/>
+          </a:solidFill>
+          <a:ln>
+            <a:noFill/>
+          </a:ln>
+        </p:spPr>
+        <p:style>
+          <a:lnRef idx="1">
+            <a:schemeClr val="accent1"/>
+          </a:lnRef>
+          <a:fillRef idx="3">
+            <a:schemeClr val="accent1"/>
+          </a:fillRef>
+          <a:effectRef idx="2">
+            <a:schemeClr val="accent1"/>
+          </a:effectRef>
+          <a:fontRef idx="minor">
+            <a:schemeClr val="lt1"/>
+          </a:fontRef>
+        </p:style>
+        <p:txBody>
+          <a:bodyPr rtlCol="0" anchor="ctr"/>
+          <a:lstStyle/>
+          <a:p>
+            <a:pPr algn="ctr"/>
+          </a:p>
+        </p:txBody>
+      </p:sp>
+      <p:sp>
+        <p:nvSpPr>
+          <p:cNvPr id="4" name="TextBox 3"/>
           <p:cNvSpPr txBox="1"/>
           <p:nvPr/>
         </p:nvSpPr>
         <p:spPr>
           <a:xfrm>
-            <a:off x="640080" y="1554480"/>
-            <a:ext cx="10972800" cy="4572000"/>
+            <a:off x="640080" y="320040"/>
+            <a:ext cx="10972800" cy="822960"/>
+          </a:xfrm>
+          <a:prstGeom prst="rect">
+            <a:avLst/>
+          </a:prstGeom>
+          <a:noFill/>
+        </p:spPr>
+        <p:txBody>
+          <a:bodyPr wrap="none">
+            <a:spAutoFit/>
+          </a:bodyPr>
+          <a:lstStyle/>
+          <a:p>
+            <a:r>
+              <a:rPr sz="3800" b="1">
+                <a:solidFill>
+                  <a:srgbClr val="FFFFFF"/>
+                </a:solidFill>
+              </a:rPr>
+              <a:t>1  What is broken</a:t>
+            </a:r>
+          </a:p>
+        </p:txBody>
+      </p:sp>
+      <p:sp>
+        <p:nvSpPr>
+          <p:cNvPr id="5" name="Rounded Rectangle 4"/>
+          <p:cNvSpPr/>
+          <p:nvPr/>
+        </p:nvSpPr>
+        <p:spPr>
+          <a:xfrm>
+            <a:off x="640080" y="1828800"/>
+            <a:ext cx="10881360" cy="960120"/>
+          </a:xfrm>
+          <a:prstGeom prst="roundRect">
+            <a:avLst/>
+          </a:prstGeom>
+          <a:solidFill>
+            <a:srgbClr val="FFFFFF"/>
+          </a:solidFill>
+          <a:ln>
+            <a:solidFill>
+              <a:srgbClr val="D5DEE8"/>
+            </a:solidFill>
+          </a:ln>
+        </p:spPr>
+        <p:style>
+          <a:lnRef idx="1">
+            <a:schemeClr val="accent1"/>
+          </a:lnRef>
+          <a:fillRef idx="3">
+            <a:schemeClr val="accent1"/>
+          </a:fillRef>
+          <a:effectRef idx="2">
+            <a:schemeClr val="accent1"/>
+          </a:effectRef>
+          <a:fontRef idx="minor">
+            <a:schemeClr val="lt1"/>
+          </a:fontRef>
+        </p:style>
+        <p:txBody>
+          <a:bodyPr rtlCol="0" anchor="ctr"/>
+          <a:lstStyle/>
+          <a:p>
+            <a:pPr algn="ctr"/>
+          </a:p>
+        </p:txBody>
+      </p:sp>
+      <p:sp>
+        <p:nvSpPr>
+          <p:cNvPr id="6" name="Rectangle 5"/>
+          <p:cNvSpPr/>
+          <p:nvPr/>
+        </p:nvSpPr>
+        <p:spPr>
+          <a:xfrm>
+            <a:off x="640080" y="1828800"/>
+            <a:ext cx="128016" cy="960120"/>
+          </a:xfrm>
+          <a:prstGeom prst="rect">
+            <a:avLst/>
+          </a:prstGeom>
+          <a:solidFill>
+            <a:srgbClr val="4677A8"/>
+          </a:solidFill>
+          <a:ln>
+            <a:noFill/>
+          </a:ln>
+        </p:spPr>
+        <p:style>
+          <a:lnRef idx="1">
+            <a:schemeClr val="accent1"/>
+          </a:lnRef>
+          <a:fillRef idx="3">
+            <a:schemeClr val="accent1"/>
+          </a:fillRef>
+          <a:effectRef idx="2">
+            <a:schemeClr val="accent1"/>
+          </a:effectRef>
+          <a:fontRef idx="minor">
+            <a:schemeClr val="lt1"/>
+          </a:fontRef>
+        </p:style>
+        <p:txBody>
+          <a:bodyPr rtlCol="0" anchor="ctr"/>
+          <a:lstStyle/>
+          <a:p>
+            <a:pPr algn="ctr"/>
+          </a:p>
+        </p:txBody>
+      </p:sp>
+      <p:sp>
+        <p:nvSpPr>
+          <p:cNvPr id="7" name="TextBox 6"/>
+          <p:cNvSpPr txBox="1"/>
+          <p:nvPr/>
+        </p:nvSpPr>
+        <p:spPr>
+          <a:xfrm>
+            <a:off x="1005840" y="1938528"/>
+            <a:ext cx="2011680" cy="731520"/>
+          </a:xfrm>
+          <a:prstGeom prst="rect">
+            <a:avLst/>
+          </a:prstGeom>
+          <a:noFill/>
+        </p:spPr>
+        <p:txBody>
+          <a:bodyPr wrap="none">
+            <a:spAutoFit/>
+          </a:bodyPr>
+          <a:lstStyle/>
+          <a:p>
+            <a:r>
+              <a:rPr sz="2000" b="1">
+                <a:solidFill>
+                  <a:srgbClr val="4677A8"/>
+                </a:solidFill>
+              </a:rPr>
+              <a:t>System</a:t>
+            </a:r>
+          </a:p>
+        </p:txBody>
+      </p:sp>
+      <p:sp>
+        <p:nvSpPr>
+          <p:cNvPr id="8" name="TextBox 7"/>
+          <p:cNvSpPr txBox="1"/>
+          <p:nvPr/>
+        </p:nvSpPr>
+        <p:spPr>
+          <a:xfrm>
+            <a:off x="3017520" y="1938528"/>
+            <a:ext cx="8321040" cy="731520"/>
           </a:xfrm>
           <a:prstGeom prst="rect">
             <a:avLst/>
@@ -3136,58 +3360,475 @@
           </a:bodyPr>
           <a:lstStyle/>
           <a:p>
-            <a:pPr>
-              <a:spcAft>
-                <a:spcPts val="1400"/>
-              </a:spcAft>
-              <a:defRPr sz="2200"/>
-            </a:pPr>
-            <a:r>
-              <a:t>• System: internal policy assistant (RAG chatbot) — synthetic case</a:t>
-            </a:r>
-          </a:p>
-          <a:p>
-            <a:pPr>
-              <a:spcAft>
-                <a:spcPts val="1400"/>
-              </a:spcAft>
-              <a:defRPr sz="2200"/>
-            </a:pPr>
-            <a:r>
-              <a:t>• Symptom: meal allowance answered as EUR 30 citing Policy v3; current v4 says EUR 40</a:t>
-            </a:r>
-          </a:p>
-          <a:p>
-            <a:pPr>
-              <a:spcAft>
-                <a:spcPts val="1400"/>
-              </a:spcAft>
-              <a:defRPr sz="2200"/>
-            </a:pPr>
-            <a:r>
-              <a:t>• Impact: wrongly rejected or under-claimed expenses, lost trust; 2 employees affected</a:t>
-            </a:r>
-          </a:p>
-          <a:p>
-            <a:pPr>
-              <a:spcAft>
-                <a:spcPts val="1400"/>
-              </a:spcAft>
-              <a:defRPr sz="2200"/>
-            </a:pPr>
-            <a:r>
-              <a:t>• Containment: 'verify in wiki' banner + fallback for travel questions</a:t>
-            </a:r>
-          </a:p>
-          <a:p>
-            <a:pPr>
-              <a:spcAft>
-                <a:spcPts val="1400"/>
-              </a:spcAft>
-              <a:defRPr sz="2200"/>
-            </a:pPr>
-            <a:r>
-              <a:t>• Facts: one failing answer, v4 exists, two users. Assumptions: pipeline, ranking, prompt</a:t>
+            <a:r>
+              <a:rPr sz="2200">
+                <a:solidFill>
+                  <a:srgbClr val="172033"/>
+                </a:solidFill>
+              </a:rPr>
+              <a:t>Policy chatbot (RAG) — synthetic case</a:t>
+            </a:r>
+          </a:p>
+        </p:txBody>
+      </p:sp>
+      <p:sp>
+        <p:nvSpPr>
+          <p:cNvPr id="9" name="Rounded Rectangle 8"/>
+          <p:cNvSpPr/>
+          <p:nvPr/>
+        </p:nvSpPr>
+        <p:spPr>
+          <a:xfrm>
+            <a:off x="640080" y="2971800"/>
+            <a:ext cx="10881360" cy="960120"/>
+          </a:xfrm>
+          <a:prstGeom prst="roundRect">
+            <a:avLst/>
+          </a:prstGeom>
+          <a:solidFill>
+            <a:srgbClr val="FFFFFF"/>
+          </a:solidFill>
+          <a:ln>
+            <a:solidFill>
+              <a:srgbClr val="D5DEE8"/>
+            </a:solidFill>
+          </a:ln>
+        </p:spPr>
+        <p:style>
+          <a:lnRef idx="1">
+            <a:schemeClr val="accent1"/>
+          </a:lnRef>
+          <a:fillRef idx="3">
+            <a:schemeClr val="accent1"/>
+          </a:fillRef>
+          <a:effectRef idx="2">
+            <a:schemeClr val="accent1"/>
+          </a:effectRef>
+          <a:fontRef idx="minor">
+            <a:schemeClr val="lt1"/>
+          </a:fontRef>
+        </p:style>
+        <p:txBody>
+          <a:bodyPr rtlCol="0" anchor="ctr"/>
+          <a:lstStyle/>
+          <a:p>
+            <a:pPr algn="ctr"/>
+          </a:p>
+        </p:txBody>
+      </p:sp>
+      <p:sp>
+        <p:nvSpPr>
+          <p:cNvPr id="10" name="Rectangle 9"/>
+          <p:cNvSpPr/>
+          <p:nvPr/>
+        </p:nvSpPr>
+        <p:spPr>
+          <a:xfrm>
+            <a:off x="640080" y="2971800"/>
+            <a:ext cx="128016" cy="960120"/>
+          </a:xfrm>
+          <a:prstGeom prst="rect">
+            <a:avLst/>
+          </a:prstGeom>
+          <a:solidFill>
+            <a:srgbClr val="4677A8"/>
+          </a:solidFill>
+          <a:ln>
+            <a:noFill/>
+          </a:ln>
+        </p:spPr>
+        <p:style>
+          <a:lnRef idx="1">
+            <a:schemeClr val="accent1"/>
+          </a:lnRef>
+          <a:fillRef idx="3">
+            <a:schemeClr val="accent1"/>
+          </a:fillRef>
+          <a:effectRef idx="2">
+            <a:schemeClr val="accent1"/>
+          </a:effectRef>
+          <a:fontRef idx="minor">
+            <a:schemeClr val="lt1"/>
+          </a:fontRef>
+        </p:style>
+        <p:txBody>
+          <a:bodyPr rtlCol="0" anchor="ctr"/>
+          <a:lstStyle/>
+          <a:p>
+            <a:pPr algn="ctr"/>
+          </a:p>
+        </p:txBody>
+      </p:sp>
+      <p:sp>
+        <p:nvSpPr>
+          <p:cNvPr id="11" name="TextBox 10"/>
+          <p:cNvSpPr txBox="1"/>
+          <p:nvPr/>
+        </p:nvSpPr>
+        <p:spPr>
+          <a:xfrm>
+            <a:off x="1005840" y="3081528"/>
+            <a:ext cx="2011680" cy="731520"/>
+          </a:xfrm>
+          <a:prstGeom prst="rect">
+            <a:avLst/>
+          </a:prstGeom>
+          <a:noFill/>
+        </p:spPr>
+        <p:txBody>
+          <a:bodyPr wrap="none">
+            <a:spAutoFit/>
+          </a:bodyPr>
+          <a:lstStyle/>
+          <a:p>
+            <a:r>
+              <a:rPr sz="2000" b="1">
+                <a:solidFill>
+                  <a:srgbClr val="4677A8"/>
+                </a:solidFill>
+              </a:rPr>
+              <a:t>Symptom</a:t>
+            </a:r>
+          </a:p>
+        </p:txBody>
+      </p:sp>
+      <p:sp>
+        <p:nvSpPr>
+          <p:cNvPr id="12" name="TextBox 11"/>
+          <p:cNvSpPr txBox="1"/>
+          <p:nvPr/>
+        </p:nvSpPr>
+        <p:spPr>
+          <a:xfrm>
+            <a:off x="3017520" y="3081528"/>
+            <a:ext cx="8321040" cy="731520"/>
+          </a:xfrm>
+          <a:prstGeom prst="rect">
+            <a:avLst/>
+          </a:prstGeom>
+          <a:noFill/>
+        </p:spPr>
+        <p:txBody>
+          <a:bodyPr wrap="square">
+            <a:spAutoFit/>
+          </a:bodyPr>
+          <a:lstStyle/>
+          <a:p>
+            <a:r>
+              <a:rPr sz="2200">
+                <a:solidFill>
+                  <a:srgbClr val="172033"/>
+                </a:solidFill>
+              </a:rPr>
+              <a:t>Says EUR 30 (policy v3); current v4 says EUR 40</a:t>
+            </a:r>
+          </a:p>
+        </p:txBody>
+      </p:sp>
+      <p:sp>
+        <p:nvSpPr>
+          <p:cNvPr id="13" name="Rounded Rectangle 12"/>
+          <p:cNvSpPr/>
+          <p:nvPr/>
+        </p:nvSpPr>
+        <p:spPr>
+          <a:xfrm>
+            <a:off x="640080" y="4114800"/>
+            <a:ext cx="10881360" cy="960120"/>
+          </a:xfrm>
+          <a:prstGeom prst="roundRect">
+            <a:avLst/>
+          </a:prstGeom>
+          <a:solidFill>
+            <a:srgbClr val="FFFFFF"/>
+          </a:solidFill>
+          <a:ln>
+            <a:solidFill>
+              <a:srgbClr val="D5DEE8"/>
+            </a:solidFill>
+          </a:ln>
+        </p:spPr>
+        <p:style>
+          <a:lnRef idx="1">
+            <a:schemeClr val="accent1"/>
+          </a:lnRef>
+          <a:fillRef idx="3">
+            <a:schemeClr val="accent1"/>
+          </a:fillRef>
+          <a:effectRef idx="2">
+            <a:schemeClr val="accent1"/>
+          </a:effectRef>
+          <a:fontRef idx="minor">
+            <a:schemeClr val="lt1"/>
+          </a:fontRef>
+        </p:style>
+        <p:txBody>
+          <a:bodyPr rtlCol="0" anchor="ctr"/>
+          <a:lstStyle/>
+          <a:p>
+            <a:pPr algn="ctr"/>
+          </a:p>
+        </p:txBody>
+      </p:sp>
+      <p:sp>
+        <p:nvSpPr>
+          <p:cNvPr id="14" name="Rectangle 13"/>
+          <p:cNvSpPr/>
+          <p:nvPr/>
+        </p:nvSpPr>
+        <p:spPr>
+          <a:xfrm>
+            <a:off x="640080" y="4114800"/>
+            <a:ext cx="128016" cy="960120"/>
+          </a:xfrm>
+          <a:prstGeom prst="rect">
+            <a:avLst/>
+          </a:prstGeom>
+          <a:solidFill>
+            <a:srgbClr val="4677A8"/>
+          </a:solidFill>
+          <a:ln>
+            <a:noFill/>
+          </a:ln>
+        </p:spPr>
+        <p:style>
+          <a:lnRef idx="1">
+            <a:schemeClr val="accent1"/>
+          </a:lnRef>
+          <a:fillRef idx="3">
+            <a:schemeClr val="accent1"/>
+          </a:fillRef>
+          <a:effectRef idx="2">
+            <a:schemeClr val="accent1"/>
+          </a:effectRef>
+          <a:fontRef idx="minor">
+            <a:schemeClr val="lt1"/>
+          </a:fontRef>
+        </p:style>
+        <p:txBody>
+          <a:bodyPr rtlCol="0" anchor="ctr"/>
+          <a:lstStyle/>
+          <a:p>
+            <a:pPr algn="ctr"/>
+          </a:p>
+        </p:txBody>
+      </p:sp>
+      <p:sp>
+        <p:nvSpPr>
+          <p:cNvPr id="15" name="TextBox 14"/>
+          <p:cNvSpPr txBox="1"/>
+          <p:nvPr/>
+        </p:nvSpPr>
+        <p:spPr>
+          <a:xfrm>
+            <a:off x="1005840" y="4224528"/>
+            <a:ext cx="2011680" cy="731520"/>
+          </a:xfrm>
+          <a:prstGeom prst="rect">
+            <a:avLst/>
+          </a:prstGeom>
+          <a:noFill/>
+        </p:spPr>
+        <p:txBody>
+          <a:bodyPr wrap="none">
+            <a:spAutoFit/>
+          </a:bodyPr>
+          <a:lstStyle/>
+          <a:p>
+            <a:r>
+              <a:rPr sz="2000" b="1">
+                <a:solidFill>
+                  <a:srgbClr val="4677A8"/>
+                </a:solidFill>
+              </a:rPr>
+              <a:t>Impact</a:t>
+            </a:r>
+          </a:p>
+        </p:txBody>
+      </p:sp>
+      <p:sp>
+        <p:nvSpPr>
+          <p:cNvPr id="16" name="TextBox 15"/>
+          <p:cNvSpPr txBox="1"/>
+          <p:nvPr/>
+        </p:nvSpPr>
+        <p:spPr>
+          <a:xfrm>
+            <a:off x="3017520" y="4224528"/>
+            <a:ext cx="8321040" cy="731520"/>
+          </a:xfrm>
+          <a:prstGeom prst="rect">
+            <a:avLst/>
+          </a:prstGeom>
+          <a:noFill/>
+        </p:spPr>
+        <p:txBody>
+          <a:bodyPr wrap="square">
+            <a:spAutoFit/>
+          </a:bodyPr>
+          <a:lstStyle/>
+          <a:p>
+            <a:r>
+              <a:rPr sz="2200">
+                <a:solidFill>
+                  <a:srgbClr val="172033"/>
+                </a:solidFill>
+              </a:rPr>
+              <a:t>Wrong expense claims, lost trust</a:t>
+            </a:r>
+          </a:p>
+        </p:txBody>
+      </p:sp>
+      <p:sp>
+        <p:nvSpPr>
+          <p:cNvPr id="17" name="Rounded Rectangle 16"/>
+          <p:cNvSpPr/>
+          <p:nvPr/>
+        </p:nvSpPr>
+        <p:spPr>
+          <a:xfrm>
+            <a:off x="640080" y="5257800"/>
+            <a:ext cx="10881360" cy="960120"/>
+          </a:xfrm>
+          <a:prstGeom prst="roundRect">
+            <a:avLst/>
+          </a:prstGeom>
+          <a:solidFill>
+            <a:srgbClr val="FFFFFF"/>
+          </a:solidFill>
+          <a:ln>
+            <a:solidFill>
+              <a:srgbClr val="D5DEE8"/>
+            </a:solidFill>
+          </a:ln>
+        </p:spPr>
+        <p:style>
+          <a:lnRef idx="1">
+            <a:schemeClr val="accent1"/>
+          </a:lnRef>
+          <a:fillRef idx="3">
+            <a:schemeClr val="accent1"/>
+          </a:fillRef>
+          <a:effectRef idx="2">
+            <a:schemeClr val="accent1"/>
+          </a:effectRef>
+          <a:fontRef idx="minor">
+            <a:schemeClr val="lt1"/>
+          </a:fontRef>
+        </p:style>
+        <p:txBody>
+          <a:bodyPr rtlCol="0" anchor="ctr"/>
+          <a:lstStyle/>
+          <a:p>
+            <a:pPr algn="ctr"/>
+          </a:p>
+        </p:txBody>
+      </p:sp>
+      <p:sp>
+        <p:nvSpPr>
+          <p:cNvPr id="18" name="Rectangle 17"/>
+          <p:cNvSpPr/>
+          <p:nvPr/>
+        </p:nvSpPr>
+        <p:spPr>
+          <a:xfrm>
+            <a:off x="640080" y="5257800"/>
+            <a:ext cx="128016" cy="960120"/>
+          </a:xfrm>
+          <a:prstGeom prst="rect">
+            <a:avLst/>
+          </a:prstGeom>
+          <a:solidFill>
+            <a:srgbClr val="4677A8"/>
+          </a:solidFill>
+          <a:ln>
+            <a:noFill/>
+          </a:ln>
+        </p:spPr>
+        <p:style>
+          <a:lnRef idx="1">
+            <a:schemeClr val="accent1"/>
+          </a:lnRef>
+          <a:fillRef idx="3">
+            <a:schemeClr val="accent1"/>
+          </a:fillRef>
+          <a:effectRef idx="2">
+            <a:schemeClr val="accent1"/>
+          </a:effectRef>
+          <a:fontRef idx="minor">
+            <a:schemeClr val="lt1"/>
+          </a:fontRef>
+        </p:style>
+        <p:txBody>
+          <a:bodyPr rtlCol="0" anchor="ctr"/>
+          <a:lstStyle/>
+          <a:p>
+            <a:pPr algn="ctr"/>
+          </a:p>
+        </p:txBody>
+      </p:sp>
+      <p:sp>
+        <p:nvSpPr>
+          <p:cNvPr id="19" name="TextBox 18"/>
+          <p:cNvSpPr txBox="1"/>
+          <p:nvPr/>
+        </p:nvSpPr>
+        <p:spPr>
+          <a:xfrm>
+            <a:off x="1005840" y="5367528"/>
+            <a:ext cx="2011680" cy="731520"/>
+          </a:xfrm>
+          <a:prstGeom prst="rect">
+            <a:avLst/>
+          </a:prstGeom>
+          <a:noFill/>
+        </p:spPr>
+        <p:txBody>
+          <a:bodyPr wrap="none">
+            <a:spAutoFit/>
+          </a:bodyPr>
+          <a:lstStyle/>
+          <a:p>
+            <a:r>
+              <a:rPr sz="2000" b="1">
+                <a:solidFill>
+                  <a:srgbClr val="4677A8"/>
+                </a:solidFill>
+              </a:rPr>
+              <a:t>Now</a:t>
+            </a:r>
+          </a:p>
+        </p:txBody>
+      </p:sp>
+      <p:sp>
+        <p:nvSpPr>
+          <p:cNvPr id="20" name="TextBox 19"/>
+          <p:cNvSpPr txBox="1"/>
+          <p:nvPr/>
+        </p:nvSpPr>
+        <p:spPr>
+          <a:xfrm>
+            <a:off x="3017520" y="5367528"/>
+            <a:ext cx="8321040" cy="731520"/>
+          </a:xfrm>
+          <a:prstGeom prst="rect">
+            <a:avLst/>
+          </a:prstGeom>
+          <a:noFill/>
+        </p:spPr>
+        <p:txBody>
+          <a:bodyPr wrap="square">
+            <a:spAutoFit/>
+          </a:bodyPr>
+          <a:lstStyle/>
+          <a:p>
+            <a:r>
+              <a:rPr sz="2200">
+                <a:solidFill>
+                  <a:srgbClr val="172033"/>
+                </a:solidFill>
+              </a:rPr>
+              <a:t>Warning banner + fallback for travel questions</a:t>
             </a:r>
           </a:p>
         </p:txBody>
@@ -3203,6 +3844,14 @@
 <file path=ppt/slides/slide2.xml><?xml version="1.0" encoding="utf-8"?>
 <p:sld xmlns:a="http://schemas.openxmlformats.org/drawingml/2006/main" xmlns:p="http://schemas.openxmlformats.org/presentationml/2006/main" xmlns:r="http://schemas.openxmlformats.org/officeDocument/2006/relationships">
   <p:cSld>
+    <p:bg>
+      <p:bgPr>
+        <a:solidFill>
+          <a:srgbClr val="F5F9FD"/>
+        </a:solidFill>
+        <a:effectLst/>
+      </p:bgPr>
+    </p:bg>
     <p:spTree>
       <p:nvGrpSpPr>
         <p:cNvPr id="1" name=""/>
@@ -3212,38 +3861,254 @@
       <p:grpSpPr/>
       <p:sp>
         <p:nvSpPr>
-          <p:cNvPr id="2" name="Title 1"/>
-          <p:cNvSpPr>
-            <a:spLocks noGrp="1"/>
-          </p:cNvSpPr>
-          <p:nvPr>
-            <p:ph type="title"/>
-          </p:nvPr>
-        </p:nvSpPr>
-        <p:spPr/>
-        <p:txBody>
-          <a:bodyPr/>
-          <a:lstStyle/>
-          <a:p>
-            <a:pPr>
-              <a:defRPr sz="3600"/>
-            </a:pPr>
-            <a:r>
-              <a:t>2. Why We Think It Is Broken</a:t>
-            </a:r>
-          </a:p>
-        </p:txBody>
-      </p:sp>
-      <p:sp>
-        <p:nvSpPr>
-          <p:cNvPr id="3" name="TextBox 2"/>
+          <p:cNvPr id="2" name="Rectangle 1"/>
+          <p:cNvSpPr/>
+          <p:nvPr/>
+        </p:nvSpPr>
+        <p:spPr>
+          <a:xfrm>
+            <a:off x="0" y="0"/>
+            <a:ext cx="12188952" cy="1371600"/>
+          </a:xfrm>
+          <a:prstGeom prst="rect">
+            <a:avLst/>
+          </a:prstGeom>
+          <a:solidFill>
+            <a:srgbClr val="172033"/>
+          </a:solidFill>
+          <a:ln>
+            <a:noFill/>
+          </a:ln>
+        </p:spPr>
+        <p:style>
+          <a:lnRef idx="1">
+            <a:schemeClr val="accent1"/>
+          </a:lnRef>
+          <a:fillRef idx="3">
+            <a:schemeClr val="accent1"/>
+          </a:fillRef>
+          <a:effectRef idx="2">
+            <a:schemeClr val="accent1"/>
+          </a:effectRef>
+          <a:fontRef idx="minor">
+            <a:schemeClr val="lt1"/>
+          </a:fontRef>
+        </p:style>
+        <p:txBody>
+          <a:bodyPr rtlCol="0" anchor="ctr"/>
+          <a:lstStyle/>
+          <a:p>
+            <a:pPr algn="ctr"/>
+          </a:p>
+        </p:txBody>
+      </p:sp>
+      <p:sp>
+        <p:nvSpPr>
+          <p:cNvPr id="3" name="Rectangle 2"/>
+          <p:cNvSpPr/>
+          <p:nvPr/>
+        </p:nvSpPr>
+        <p:spPr>
+          <a:xfrm>
+            <a:off x="0" y="1371600"/>
+            <a:ext cx="12188952" cy="73152"/>
+          </a:xfrm>
+          <a:prstGeom prst="rect">
+            <a:avLst/>
+          </a:prstGeom>
+          <a:solidFill>
+            <a:srgbClr val="3B8A5A"/>
+          </a:solidFill>
+          <a:ln>
+            <a:noFill/>
+          </a:ln>
+        </p:spPr>
+        <p:style>
+          <a:lnRef idx="1">
+            <a:schemeClr val="accent1"/>
+          </a:lnRef>
+          <a:fillRef idx="3">
+            <a:schemeClr val="accent1"/>
+          </a:fillRef>
+          <a:effectRef idx="2">
+            <a:schemeClr val="accent1"/>
+          </a:effectRef>
+          <a:fontRef idx="minor">
+            <a:schemeClr val="lt1"/>
+          </a:fontRef>
+        </p:style>
+        <p:txBody>
+          <a:bodyPr rtlCol="0" anchor="ctr"/>
+          <a:lstStyle/>
+          <a:p>
+            <a:pPr algn="ctr"/>
+          </a:p>
+        </p:txBody>
+      </p:sp>
+      <p:sp>
+        <p:nvSpPr>
+          <p:cNvPr id="4" name="TextBox 3"/>
           <p:cNvSpPr txBox="1"/>
           <p:nvPr/>
         </p:nvSpPr>
         <p:spPr>
           <a:xfrm>
-            <a:off x="640080" y="1554480"/>
-            <a:ext cx="10972800" cy="4572000"/>
+            <a:off x="640080" y="320040"/>
+            <a:ext cx="10972800" cy="822960"/>
+          </a:xfrm>
+          <a:prstGeom prst="rect">
+            <a:avLst/>
+          </a:prstGeom>
+          <a:noFill/>
+        </p:spPr>
+        <p:txBody>
+          <a:bodyPr wrap="none">
+            <a:spAutoFit/>
+          </a:bodyPr>
+          <a:lstStyle/>
+          <a:p>
+            <a:r>
+              <a:rPr sz="3800" b="1">
+                <a:solidFill>
+                  <a:srgbClr val="FFFFFF"/>
+                </a:solidFill>
+              </a:rPr>
+              <a:t>2  Why we think so</a:t>
+            </a:r>
+          </a:p>
+        </p:txBody>
+      </p:sp>
+      <p:sp>
+        <p:nvSpPr>
+          <p:cNvPr id="5" name="Rounded Rectangle 4"/>
+          <p:cNvSpPr/>
+          <p:nvPr/>
+        </p:nvSpPr>
+        <p:spPr>
+          <a:xfrm>
+            <a:off x="640080" y="1828800"/>
+            <a:ext cx="10881360" cy="960120"/>
+          </a:xfrm>
+          <a:prstGeom prst="roundRect">
+            <a:avLst/>
+          </a:prstGeom>
+          <a:solidFill>
+            <a:srgbClr val="FFFFFF"/>
+          </a:solidFill>
+          <a:ln>
+            <a:solidFill>
+              <a:srgbClr val="D5DEE8"/>
+            </a:solidFill>
+          </a:ln>
+        </p:spPr>
+        <p:style>
+          <a:lnRef idx="1">
+            <a:schemeClr val="accent1"/>
+          </a:lnRef>
+          <a:fillRef idx="3">
+            <a:schemeClr val="accent1"/>
+          </a:fillRef>
+          <a:effectRef idx="2">
+            <a:schemeClr val="accent1"/>
+          </a:effectRef>
+          <a:fontRef idx="minor">
+            <a:schemeClr val="lt1"/>
+          </a:fontRef>
+        </p:style>
+        <p:txBody>
+          <a:bodyPr rtlCol="0" anchor="ctr"/>
+          <a:lstStyle/>
+          <a:p>
+            <a:pPr algn="ctr"/>
+          </a:p>
+        </p:txBody>
+      </p:sp>
+      <p:sp>
+        <p:nvSpPr>
+          <p:cNvPr id="6" name="Rectangle 5"/>
+          <p:cNvSpPr/>
+          <p:nvPr/>
+        </p:nvSpPr>
+        <p:spPr>
+          <a:xfrm>
+            <a:off x="640080" y="1828800"/>
+            <a:ext cx="128016" cy="960120"/>
+          </a:xfrm>
+          <a:prstGeom prst="rect">
+            <a:avLst/>
+          </a:prstGeom>
+          <a:solidFill>
+            <a:srgbClr val="3B8A5A"/>
+          </a:solidFill>
+          <a:ln>
+            <a:noFill/>
+          </a:ln>
+        </p:spPr>
+        <p:style>
+          <a:lnRef idx="1">
+            <a:schemeClr val="accent1"/>
+          </a:lnRef>
+          <a:fillRef idx="3">
+            <a:schemeClr val="accent1"/>
+          </a:fillRef>
+          <a:effectRef idx="2">
+            <a:schemeClr val="accent1"/>
+          </a:effectRef>
+          <a:fontRef idx="minor">
+            <a:schemeClr val="lt1"/>
+          </a:fontRef>
+        </p:style>
+        <p:txBody>
+          <a:bodyPr rtlCol="0" anchor="ctr"/>
+          <a:lstStyle/>
+          <a:p>
+            <a:pPr algn="ctr"/>
+          </a:p>
+        </p:txBody>
+      </p:sp>
+      <p:sp>
+        <p:nvSpPr>
+          <p:cNvPr id="7" name="TextBox 6"/>
+          <p:cNvSpPr txBox="1"/>
+          <p:nvPr/>
+        </p:nvSpPr>
+        <p:spPr>
+          <a:xfrm>
+            <a:off x="1005840" y="1938528"/>
+            <a:ext cx="2011680" cy="731520"/>
+          </a:xfrm>
+          <a:prstGeom prst="rect">
+            <a:avLst/>
+          </a:prstGeom>
+          <a:noFill/>
+        </p:spPr>
+        <p:txBody>
+          <a:bodyPr wrap="none">
+            <a:spAutoFit/>
+          </a:bodyPr>
+          <a:lstStyle/>
+          <a:p>
+            <a:r>
+              <a:rPr sz="2000" b="1">
+                <a:solidFill>
+                  <a:srgbClr val="3B8A5A"/>
+                </a:solidFill>
+              </a:rPr>
+              <a:t>1</a:t>
+            </a:r>
+          </a:p>
+        </p:txBody>
+      </p:sp>
+      <p:sp>
+        <p:nvSpPr>
+          <p:cNvPr id="8" name="TextBox 7"/>
+          <p:cNvSpPr txBox="1"/>
+          <p:nvPr/>
+        </p:nvSpPr>
+        <p:spPr>
+          <a:xfrm>
+            <a:off x="3017520" y="1938528"/>
+            <a:ext cx="8321040" cy="731520"/>
           </a:xfrm>
           <a:prstGeom prst="rect">
             <a:avLst/>
@@ -3256,58 +4121,475 @@
           </a:bodyPr>
           <a:lstStyle/>
           <a:p>
-            <a:pPr>
-              <a:spcAft>
-                <a:spcPts val="1400"/>
-              </a:spcAft>
-              <a:defRPr sz="2200"/>
-            </a:pPr>
-            <a:r>
-              <a:t>• #1 Ingestion gap: v4 not indexed / v3 not superseded — Medium</a:t>
-            </a:r>
-          </a:p>
-          <a:p>
-            <a:pPr>
-              <a:spcAft>
-                <a:spcPts val="1400"/>
-              </a:spcAft>
-              <a:defRPr sz="2200"/>
-            </a:pPr>
-            <a:r>
-              <a:t>• #2 Ranking: v3 outranks v4 in retrieval — Medium</a:t>
-            </a:r>
-          </a:p>
-          <a:p>
-            <a:pPr>
-              <a:spcAft>
-                <a:spcPts val="1400"/>
-              </a:spcAft>
-              <a:defRPr sz="2200"/>
-            </a:pPr>
-            <a:r>
-              <a:t>• #3 Generation: model picks v3 from mixed context — Low</a:t>
-            </a:r>
-          </a:p>
-          <a:p>
-            <a:pPr>
-              <a:spcAft>
-                <a:spcPts val="1400"/>
-              </a:spcAft>
-              <a:defRPr sz="2200"/>
-            </a:pPr>
-            <a:r>
-              <a:t>• Missing evidence: retrieved passages, index contents, config versions</a:t>
-            </a:r>
-          </a:p>
-          <a:p>
-            <a:pPr>
-              <a:spcAft>
-                <a:spcPts val="1400"/>
-              </a:spcAft>
-              <a:defRPr sz="2200"/>
-            </a:pPr>
-            <a:r>
-              <a:t>• Next test: retrieval trace. v4 absent = ingestion; lower-ranked = ranking; top-ranked but ignored = generation</a:t>
+            <a:r>
+              <a:rPr sz="2200">
+                <a:solidFill>
+                  <a:srgbClr val="172033"/>
+                </a:solidFill>
+              </a:rPr>
+              <a:t>Ingestion gap: v4 not indexed (Medium)</a:t>
+            </a:r>
+          </a:p>
+        </p:txBody>
+      </p:sp>
+      <p:sp>
+        <p:nvSpPr>
+          <p:cNvPr id="9" name="Rounded Rectangle 8"/>
+          <p:cNvSpPr/>
+          <p:nvPr/>
+        </p:nvSpPr>
+        <p:spPr>
+          <a:xfrm>
+            <a:off x="640080" y="2971800"/>
+            <a:ext cx="10881360" cy="960120"/>
+          </a:xfrm>
+          <a:prstGeom prst="roundRect">
+            <a:avLst/>
+          </a:prstGeom>
+          <a:solidFill>
+            <a:srgbClr val="FFFFFF"/>
+          </a:solidFill>
+          <a:ln>
+            <a:solidFill>
+              <a:srgbClr val="D5DEE8"/>
+            </a:solidFill>
+          </a:ln>
+        </p:spPr>
+        <p:style>
+          <a:lnRef idx="1">
+            <a:schemeClr val="accent1"/>
+          </a:lnRef>
+          <a:fillRef idx="3">
+            <a:schemeClr val="accent1"/>
+          </a:fillRef>
+          <a:effectRef idx="2">
+            <a:schemeClr val="accent1"/>
+          </a:effectRef>
+          <a:fontRef idx="minor">
+            <a:schemeClr val="lt1"/>
+          </a:fontRef>
+        </p:style>
+        <p:txBody>
+          <a:bodyPr rtlCol="0" anchor="ctr"/>
+          <a:lstStyle/>
+          <a:p>
+            <a:pPr algn="ctr"/>
+          </a:p>
+        </p:txBody>
+      </p:sp>
+      <p:sp>
+        <p:nvSpPr>
+          <p:cNvPr id="10" name="Rectangle 9"/>
+          <p:cNvSpPr/>
+          <p:nvPr/>
+        </p:nvSpPr>
+        <p:spPr>
+          <a:xfrm>
+            <a:off x="640080" y="2971800"/>
+            <a:ext cx="128016" cy="960120"/>
+          </a:xfrm>
+          <a:prstGeom prst="rect">
+            <a:avLst/>
+          </a:prstGeom>
+          <a:solidFill>
+            <a:srgbClr val="3B8A5A"/>
+          </a:solidFill>
+          <a:ln>
+            <a:noFill/>
+          </a:ln>
+        </p:spPr>
+        <p:style>
+          <a:lnRef idx="1">
+            <a:schemeClr val="accent1"/>
+          </a:lnRef>
+          <a:fillRef idx="3">
+            <a:schemeClr val="accent1"/>
+          </a:fillRef>
+          <a:effectRef idx="2">
+            <a:schemeClr val="accent1"/>
+          </a:effectRef>
+          <a:fontRef idx="minor">
+            <a:schemeClr val="lt1"/>
+          </a:fontRef>
+        </p:style>
+        <p:txBody>
+          <a:bodyPr rtlCol="0" anchor="ctr"/>
+          <a:lstStyle/>
+          <a:p>
+            <a:pPr algn="ctr"/>
+          </a:p>
+        </p:txBody>
+      </p:sp>
+      <p:sp>
+        <p:nvSpPr>
+          <p:cNvPr id="11" name="TextBox 10"/>
+          <p:cNvSpPr txBox="1"/>
+          <p:nvPr/>
+        </p:nvSpPr>
+        <p:spPr>
+          <a:xfrm>
+            <a:off x="1005840" y="3081528"/>
+            <a:ext cx="2011680" cy="731520"/>
+          </a:xfrm>
+          <a:prstGeom prst="rect">
+            <a:avLst/>
+          </a:prstGeom>
+          <a:noFill/>
+        </p:spPr>
+        <p:txBody>
+          <a:bodyPr wrap="none">
+            <a:spAutoFit/>
+          </a:bodyPr>
+          <a:lstStyle/>
+          <a:p>
+            <a:r>
+              <a:rPr sz="2000" b="1">
+                <a:solidFill>
+                  <a:srgbClr val="3B8A5A"/>
+                </a:solidFill>
+              </a:rPr>
+              <a:t>2</a:t>
+            </a:r>
+          </a:p>
+        </p:txBody>
+      </p:sp>
+      <p:sp>
+        <p:nvSpPr>
+          <p:cNvPr id="12" name="TextBox 11"/>
+          <p:cNvSpPr txBox="1"/>
+          <p:nvPr/>
+        </p:nvSpPr>
+        <p:spPr>
+          <a:xfrm>
+            <a:off x="3017520" y="3081528"/>
+            <a:ext cx="8321040" cy="731520"/>
+          </a:xfrm>
+          <a:prstGeom prst="rect">
+            <a:avLst/>
+          </a:prstGeom>
+          <a:noFill/>
+        </p:spPr>
+        <p:txBody>
+          <a:bodyPr wrap="square">
+            <a:spAutoFit/>
+          </a:bodyPr>
+          <a:lstStyle/>
+          <a:p>
+            <a:r>
+              <a:rPr sz="2200">
+                <a:solidFill>
+                  <a:srgbClr val="172033"/>
+                </a:solidFill>
+              </a:rPr>
+              <a:t>Ranking: v3 outranks v4 (Medium)</a:t>
+            </a:r>
+          </a:p>
+        </p:txBody>
+      </p:sp>
+      <p:sp>
+        <p:nvSpPr>
+          <p:cNvPr id="13" name="Rounded Rectangle 12"/>
+          <p:cNvSpPr/>
+          <p:nvPr/>
+        </p:nvSpPr>
+        <p:spPr>
+          <a:xfrm>
+            <a:off x="640080" y="4114800"/>
+            <a:ext cx="10881360" cy="960120"/>
+          </a:xfrm>
+          <a:prstGeom prst="roundRect">
+            <a:avLst/>
+          </a:prstGeom>
+          <a:solidFill>
+            <a:srgbClr val="FFFFFF"/>
+          </a:solidFill>
+          <a:ln>
+            <a:solidFill>
+              <a:srgbClr val="D5DEE8"/>
+            </a:solidFill>
+          </a:ln>
+        </p:spPr>
+        <p:style>
+          <a:lnRef idx="1">
+            <a:schemeClr val="accent1"/>
+          </a:lnRef>
+          <a:fillRef idx="3">
+            <a:schemeClr val="accent1"/>
+          </a:fillRef>
+          <a:effectRef idx="2">
+            <a:schemeClr val="accent1"/>
+          </a:effectRef>
+          <a:fontRef idx="minor">
+            <a:schemeClr val="lt1"/>
+          </a:fontRef>
+        </p:style>
+        <p:txBody>
+          <a:bodyPr rtlCol="0" anchor="ctr"/>
+          <a:lstStyle/>
+          <a:p>
+            <a:pPr algn="ctr"/>
+          </a:p>
+        </p:txBody>
+      </p:sp>
+      <p:sp>
+        <p:nvSpPr>
+          <p:cNvPr id="14" name="Rectangle 13"/>
+          <p:cNvSpPr/>
+          <p:nvPr/>
+        </p:nvSpPr>
+        <p:spPr>
+          <a:xfrm>
+            <a:off x="640080" y="4114800"/>
+            <a:ext cx="128016" cy="960120"/>
+          </a:xfrm>
+          <a:prstGeom prst="rect">
+            <a:avLst/>
+          </a:prstGeom>
+          <a:solidFill>
+            <a:srgbClr val="3B8A5A"/>
+          </a:solidFill>
+          <a:ln>
+            <a:noFill/>
+          </a:ln>
+        </p:spPr>
+        <p:style>
+          <a:lnRef idx="1">
+            <a:schemeClr val="accent1"/>
+          </a:lnRef>
+          <a:fillRef idx="3">
+            <a:schemeClr val="accent1"/>
+          </a:fillRef>
+          <a:effectRef idx="2">
+            <a:schemeClr val="accent1"/>
+          </a:effectRef>
+          <a:fontRef idx="minor">
+            <a:schemeClr val="lt1"/>
+          </a:fontRef>
+        </p:style>
+        <p:txBody>
+          <a:bodyPr rtlCol="0" anchor="ctr"/>
+          <a:lstStyle/>
+          <a:p>
+            <a:pPr algn="ctr"/>
+          </a:p>
+        </p:txBody>
+      </p:sp>
+      <p:sp>
+        <p:nvSpPr>
+          <p:cNvPr id="15" name="TextBox 14"/>
+          <p:cNvSpPr txBox="1"/>
+          <p:nvPr/>
+        </p:nvSpPr>
+        <p:spPr>
+          <a:xfrm>
+            <a:off x="1005840" y="4224528"/>
+            <a:ext cx="2011680" cy="731520"/>
+          </a:xfrm>
+          <a:prstGeom prst="rect">
+            <a:avLst/>
+          </a:prstGeom>
+          <a:noFill/>
+        </p:spPr>
+        <p:txBody>
+          <a:bodyPr wrap="none">
+            <a:spAutoFit/>
+          </a:bodyPr>
+          <a:lstStyle/>
+          <a:p>
+            <a:r>
+              <a:rPr sz="2000" b="1">
+                <a:solidFill>
+                  <a:srgbClr val="3B8A5A"/>
+                </a:solidFill>
+              </a:rPr>
+              <a:t>3</a:t>
+            </a:r>
+          </a:p>
+        </p:txBody>
+      </p:sp>
+      <p:sp>
+        <p:nvSpPr>
+          <p:cNvPr id="16" name="TextBox 15"/>
+          <p:cNvSpPr txBox="1"/>
+          <p:nvPr/>
+        </p:nvSpPr>
+        <p:spPr>
+          <a:xfrm>
+            <a:off x="3017520" y="4224528"/>
+            <a:ext cx="8321040" cy="731520"/>
+          </a:xfrm>
+          <a:prstGeom prst="rect">
+            <a:avLst/>
+          </a:prstGeom>
+          <a:noFill/>
+        </p:spPr>
+        <p:txBody>
+          <a:bodyPr wrap="square">
+            <a:spAutoFit/>
+          </a:bodyPr>
+          <a:lstStyle/>
+          <a:p>
+            <a:r>
+              <a:rPr sz="2200">
+                <a:solidFill>
+                  <a:srgbClr val="172033"/>
+                </a:solidFill>
+              </a:rPr>
+              <a:t>Model picks v3 from mixed context (Low)</a:t>
+            </a:r>
+          </a:p>
+        </p:txBody>
+      </p:sp>
+      <p:sp>
+        <p:nvSpPr>
+          <p:cNvPr id="17" name="Rounded Rectangle 16"/>
+          <p:cNvSpPr/>
+          <p:nvPr/>
+        </p:nvSpPr>
+        <p:spPr>
+          <a:xfrm>
+            <a:off x="640080" y="5257800"/>
+            <a:ext cx="10881360" cy="960120"/>
+          </a:xfrm>
+          <a:prstGeom prst="roundRect">
+            <a:avLst/>
+          </a:prstGeom>
+          <a:solidFill>
+            <a:srgbClr val="FFFFFF"/>
+          </a:solidFill>
+          <a:ln>
+            <a:solidFill>
+              <a:srgbClr val="D5DEE8"/>
+            </a:solidFill>
+          </a:ln>
+        </p:spPr>
+        <p:style>
+          <a:lnRef idx="1">
+            <a:schemeClr val="accent1"/>
+          </a:lnRef>
+          <a:fillRef idx="3">
+            <a:schemeClr val="accent1"/>
+          </a:fillRef>
+          <a:effectRef idx="2">
+            <a:schemeClr val="accent1"/>
+          </a:effectRef>
+          <a:fontRef idx="minor">
+            <a:schemeClr val="lt1"/>
+          </a:fontRef>
+        </p:style>
+        <p:txBody>
+          <a:bodyPr rtlCol="0" anchor="ctr"/>
+          <a:lstStyle/>
+          <a:p>
+            <a:pPr algn="ctr"/>
+          </a:p>
+        </p:txBody>
+      </p:sp>
+      <p:sp>
+        <p:nvSpPr>
+          <p:cNvPr id="18" name="Rectangle 17"/>
+          <p:cNvSpPr/>
+          <p:nvPr/>
+        </p:nvSpPr>
+        <p:spPr>
+          <a:xfrm>
+            <a:off x="640080" y="5257800"/>
+            <a:ext cx="128016" cy="960120"/>
+          </a:xfrm>
+          <a:prstGeom prst="rect">
+            <a:avLst/>
+          </a:prstGeom>
+          <a:solidFill>
+            <a:srgbClr val="3B8A5A"/>
+          </a:solidFill>
+          <a:ln>
+            <a:noFill/>
+          </a:ln>
+        </p:spPr>
+        <p:style>
+          <a:lnRef idx="1">
+            <a:schemeClr val="accent1"/>
+          </a:lnRef>
+          <a:fillRef idx="3">
+            <a:schemeClr val="accent1"/>
+          </a:fillRef>
+          <a:effectRef idx="2">
+            <a:schemeClr val="accent1"/>
+          </a:effectRef>
+          <a:fontRef idx="minor">
+            <a:schemeClr val="lt1"/>
+          </a:fontRef>
+        </p:style>
+        <p:txBody>
+          <a:bodyPr rtlCol="0" anchor="ctr"/>
+          <a:lstStyle/>
+          <a:p>
+            <a:pPr algn="ctr"/>
+          </a:p>
+        </p:txBody>
+      </p:sp>
+      <p:sp>
+        <p:nvSpPr>
+          <p:cNvPr id="19" name="TextBox 18"/>
+          <p:cNvSpPr txBox="1"/>
+          <p:nvPr/>
+        </p:nvSpPr>
+        <p:spPr>
+          <a:xfrm>
+            <a:off x="1005840" y="5367528"/>
+            <a:ext cx="2011680" cy="731520"/>
+          </a:xfrm>
+          <a:prstGeom prst="rect">
+            <a:avLst/>
+          </a:prstGeom>
+          <a:noFill/>
+        </p:spPr>
+        <p:txBody>
+          <a:bodyPr wrap="none">
+            <a:spAutoFit/>
+          </a:bodyPr>
+          <a:lstStyle/>
+          <a:p>
+            <a:r>
+              <a:rPr sz="2000" b="1">
+                <a:solidFill>
+                  <a:srgbClr val="3B8A5A"/>
+                </a:solidFill>
+              </a:rPr>
+              <a:t>Next test</a:t>
+            </a:r>
+          </a:p>
+        </p:txBody>
+      </p:sp>
+      <p:sp>
+        <p:nvSpPr>
+          <p:cNvPr id="20" name="TextBox 19"/>
+          <p:cNvSpPr txBox="1"/>
+          <p:nvPr/>
+        </p:nvSpPr>
+        <p:spPr>
+          <a:xfrm>
+            <a:off x="3017520" y="5367528"/>
+            <a:ext cx="8321040" cy="731520"/>
+          </a:xfrm>
+          <a:prstGeom prst="rect">
+            <a:avLst/>
+          </a:prstGeom>
+          <a:noFill/>
+        </p:spPr>
+        <p:txBody>
+          <a:bodyPr wrap="square">
+            <a:spAutoFit/>
+          </a:bodyPr>
+          <a:lstStyle/>
+          <a:p>
+            <a:r>
+              <a:rPr sz="2200">
+                <a:solidFill>
+                  <a:srgbClr val="172033"/>
+                </a:solidFill>
+              </a:rPr>
+              <a:t>Retrieval trace for the failing question</a:t>
             </a:r>
           </a:p>
         </p:txBody>
@@ -3323,6 +4605,14 @@
 <file path=ppt/slides/slide3.xml><?xml version="1.0" encoding="utf-8"?>
 <p:sld xmlns:a="http://schemas.openxmlformats.org/drawingml/2006/main" xmlns:p="http://schemas.openxmlformats.org/presentationml/2006/main" xmlns:r="http://schemas.openxmlformats.org/officeDocument/2006/relationships">
   <p:cSld>
+    <p:bg>
+      <p:bgPr>
+        <a:solidFill>
+          <a:srgbClr val="F5F9FD"/>
+        </a:solidFill>
+        <a:effectLst/>
+      </p:bgPr>
+    </p:bg>
     <p:spTree>
       <p:nvGrpSpPr>
         <p:cNvPr id="1" name=""/>
@@ -3332,38 +4622,254 @@
       <p:grpSpPr/>
       <p:sp>
         <p:nvSpPr>
-          <p:cNvPr id="2" name="Title 1"/>
-          <p:cNvSpPr>
-            <a:spLocks noGrp="1"/>
-          </p:cNvSpPr>
-          <p:nvPr>
-            <p:ph type="title"/>
-          </p:nvPr>
-        </p:nvSpPr>
-        <p:spPr/>
-        <p:txBody>
-          <a:bodyPr/>
-          <a:lstStyle/>
-          <a:p>
-            <a:pPr>
-              <a:defRPr sz="3600"/>
-            </a:pPr>
-            <a:r>
-              <a:t>3. What We Recommend</a:t>
-            </a:r>
-          </a:p>
-        </p:txBody>
-      </p:sp>
-      <p:sp>
-        <p:nvSpPr>
-          <p:cNvPr id="3" name="TextBox 2"/>
+          <p:cNvPr id="2" name="Rectangle 1"/>
+          <p:cNvSpPr/>
+          <p:nvPr/>
+        </p:nvSpPr>
+        <p:spPr>
+          <a:xfrm>
+            <a:off x="0" y="0"/>
+            <a:ext cx="12188952" cy="1371600"/>
+          </a:xfrm>
+          <a:prstGeom prst="rect">
+            <a:avLst/>
+          </a:prstGeom>
+          <a:solidFill>
+            <a:srgbClr val="172033"/>
+          </a:solidFill>
+          <a:ln>
+            <a:noFill/>
+          </a:ln>
+        </p:spPr>
+        <p:style>
+          <a:lnRef idx="1">
+            <a:schemeClr val="accent1"/>
+          </a:lnRef>
+          <a:fillRef idx="3">
+            <a:schemeClr val="accent1"/>
+          </a:fillRef>
+          <a:effectRef idx="2">
+            <a:schemeClr val="accent1"/>
+          </a:effectRef>
+          <a:fontRef idx="minor">
+            <a:schemeClr val="lt1"/>
+          </a:fontRef>
+        </p:style>
+        <p:txBody>
+          <a:bodyPr rtlCol="0" anchor="ctr"/>
+          <a:lstStyle/>
+          <a:p>
+            <a:pPr algn="ctr"/>
+          </a:p>
+        </p:txBody>
+      </p:sp>
+      <p:sp>
+        <p:nvSpPr>
+          <p:cNvPr id="3" name="Rectangle 2"/>
+          <p:cNvSpPr/>
+          <p:nvPr/>
+        </p:nvSpPr>
+        <p:spPr>
+          <a:xfrm>
+            <a:off x="0" y="1371600"/>
+            <a:ext cx="12188952" cy="73152"/>
+          </a:xfrm>
+          <a:prstGeom prst="rect">
+            <a:avLst/>
+          </a:prstGeom>
+          <a:solidFill>
+            <a:srgbClr val="B77A1F"/>
+          </a:solidFill>
+          <a:ln>
+            <a:noFill/>
+          </a:ln>
+        </p:spPr>
+        <p:style>
+          <a:lnRef idx="1">
+            <a:schemeClr val="accent1"/>
+          </a:lnRef>
+          <a:fillRef idx="3">
+            <a:schemeClr val="accent1"/>
+          </a:fillRef>
+          <a:effectRef idx="2">
+            <a:schemeClr val="accent1"/>
+          </a:effectRef>
+          <a:fontRef idx="minor">
+            <a:schemeClr val="lt1"/>
+          </a:fontRef>
+        </p:style>
+        <p:txBody>
+          <a:bodyPr rtlCol="0" anchor="ctr"/>
+          <a:lstStyle/>
+          <a:p>
+            <a:pPr algn="ctr"/>
+          </a:p>
+        </p:txBody>
+      </p:sp>
+      <p:sp>
+        <p:nvSpPr>
+          <p:cNvPr id="4" name="TextBox 3"/>
           <p:cNvSpPr txBox="1"/>
           <p:nvPr/>
         </p:nvSpPr>
         <p:spPr>
           <a:xfrm>
-            <a:off x="640080" y="1554480"/>
-            <a:ext cx="10972800" cy="4572000"/>
+            <a:off x="640080" y="320040"/>
+            <a:ext cx="10972800" cy="822960"/>
+          </a:xfrm>
+          <a:prstGeom prst="rect">
+            <a:avLst/>
+          </a:prstGeom>
+          <a:noFill/>
+        </p:spPr>
+        <p:txBody>
+          <a:bodyPr wrap="none">
+            <a:spAutoFit/>
+          </a:bodyPr>
+          <a:lstStyle/>
+          <a:p>
+            <a:r>
+              <a:rPr sz="3800" b="1">
+                <a:solidFill>
+                  <a:srgbClr val="FFFFFF"/>
+                </a:solidFill>
+              </a:rPr>
+              <a:t>3  What we recommend</a:t>
+            </a:r>
+          </a:p>
+        </p:txBody>
+      </p:sp>
+      <p:sp>
+        <p:nvSpPr>
+          <p:cNvPr id="5" name="Rounded Rectangle 4"/>
+          <p:cNvSpPr/>
+          <p:nvPr/>
+        </p:nvSpPr>
+        <p:spPr>
+          <a:xfrm>
+            <a:off x="640080" y="1828800"/>
+            <a:ext cx="10881360" cy="960120"/>
+          </a:xfrm>
+          <a:prstGeom prst="roundRect">
+            <a:avLst/>
+          </a:prstGeom>
+          <a:solidFill>
+            <a:srgbClr val="FFFFFF"/>
+          </a:solidFill>
+          <a:ln>
+            <a:solidFill>
+              <a:srgbClr val="D5DEE8"/>
+            </a:solidFill>
+          </a:ln>
+        </p:spPr>
+        <p:style>
+          <a:lnRef idx="1">
+            <a:schemeClr val="accent1"/>
+          </a:lnRef>
+          <a:fillRef idx="3">
+            <a:schemeClr val="accent1"/>
+          </a:fillRef>
+          <a:effectRef idx="2">
+            <a:schemeClr val="accent1"/>
+          </a:effectRef>
+          <a:fontRef idx="minor">
+            <a:schemeClr val="lt1"/>
+          </a:fontRef>
+        </p:style>
+        <p:txBody>
+          <a:bodyPr rtlCol="0" anchor="ctr"/>
+          <a:lstStyle/>
+          <a:p>
+            <a:pPr algn="ctr"/>
+          </a:p>
+        </p:txBody>
+      </p:sp>
+      <p:sp>
+        <p:nvSpPr>
+          <p:cNvPr id="6" name="Rectangle 5"/>
+          <p:cNvSpPr/>
+          <p:nvPr/>
+        </p:nvSpPr>
+        <p:spPr>
+          <a:xfrm>
+            <a:off x="640080" y="1828800"/>
+            <a:ext cx="128016" cy="960120"/>
+          </a:xfrm>
+          <a:prstGeom prst="rect">
+            <a:avLst/>
+          </a:prstGeom>
+          <a:solidFill>
+            <a:srgbClr val="B77A1F"/>
+          </a:solidFill>
+          <a:ln>
+            <a:noFill/>
+          </a:ln>
+        </p:spPr>
+        <p:style>
+          <a:lnRef idx="1">
+            <a:schemeClr val="accent1"/>
+          </a:lnRef>
+          <a:fillRef idx="3">
+            <a:schemeClr val="accent1"/>
+          </a:fillRef>
+          <a:effectRef idx="2">
+            <a:schemeClr val="accent1"/>
+          </a:effectRef>
+          <a:fontRef idx="minor">
+            <a:schemeClr val="lt1"/>
+          </a:fontRef>
+        </p:style>
+        <p:txBody>
+          <a:bodyPr rtlCol="0" anchor="ctr"/>
+          <a:lstStyle/>
+          <a:p>
+            <a:pPr algn="ctr"/>
+          </a:p>
+        </p:txBody>
+      </p:sp>
+      <p:sp>
+        <p:nvSpPr>
+          <p:cNvPr id="7" name="TextBox 6"/>
+          <p:cNvSpPr txBox="1"/>
+          <p:nvPr/>
+        </p:nvSpPr>
+        <p:spPr>
+          <a:xfrm>
+            <a:off x="1005840" y="1938528"/>
+            <a:ext cx="2011680" cy="731520"/>
+          </a:xfrm>
+          <a:prstGeom prst="rect">
+            <a:avLst/>
+          </a:prstGeom>
+          <a:noFill/>
+        </p:spPr>
+        <p:txBody>
+          <a:bodyPr wrap="none">
+            <a:spAutoFit/>
+          </a:bodyPr>
+          <a:lstStyle/>
+          <a:p>
+            <a:r>
+              <a:rPr sz="2000" b="1">
+                <a:solidFill>
+                  <a:srgbClr val="B77A1F"/>
+                </a:solidFill>
+              </a:rPr>
+              <a:t>Decision</a:t>
+            </a:r>
+          </a:p>
+        </p:txBody>
+      </p:sp>
+      <p:sp>
+        <p:nvSpPr>
+          <p:cNvPr id="8" name="TextBox 7"/>
+          <p:cNvSpPr txBox="1"/>
+          <p:nvPr/>
+        </p:nvSpPr>
+        <p:spPr>
+          <a:xfrm>
+            <a:off x="3017520" y="1938528"/>
+            <a:ext cx="8321040" cy="731520"/>
           </a:xfrm>
           <a:prstGeom prst="rect">
             <a:avLst/>
@@ -3376,58 +4882,475 @@
           </a:bodyPr>
           <a:lstStyle/>
           <a:p>
-            <a:pPr>
-              <a:spcAft>
-                <a:spcPts val="1400"/>
-              </a:spcAft>
-              <a:defRPr sz="2200"/>
-            </a:pPr>
-            <a:r>
-              <a:t>• Decision: contain, then investigate — no rollback, no fine-tuning</a:t>
-            </a:r>
-          </a:p>
-          <a:p>
-            <a:pPr>
-              <a:spcAft>
-                <a:spcPts val="1400"/>
-              </a:spcAft>
-              <a:defRPr sz="2200"/>
-            </a:pPr>
-            <a:r>
-              <a:t>• Plan: banner + fallback; trace + index audit; sample 10 other policies; smallest fix; regression case + drift alert</a:t>
-            </a:r>
-          </a:p>
-          <a:p>
-            <a:pPr>
-              <a:spcAft>
-                <a:spcPts val="1400"/>
-              </a:spcAft>
-              <a:defRPr sz="2200"/>
-            </a:pPr>
-            <a:r>
-              <a:t>• Proof of recovery: original case passes; 95%+ on 30 cases; zero superseded citations; drift alert within 24h</a:t>
-            </a:r>
-          </a:p>
-          <a:p>
-            <a:pPr>
-              <a:spcAft>
-                <a:spcPts val="1400"/>
-              </a:spcAft>
-              <a:defRPr sz="2200"/>
-            </a:pPr>
-            <a:r>
-              <a:t>• Owner: Head of People Ops + AI platform lead</a:t>
-            </a:r>
-          </a:p>
-          <a:p>
-            <a:pPr>
-              <a:spcAft>
-                <a:spcPts val="1400"/>
-              </a:spcAft>
-              <a:defRPr sz="2200"/>
-            </a:pPr>
-            <a:r>
-              <a:t>• Would change the plan: many stale policies -&gt; pause policy topics; permission leak -&gt; pause now</a:t>
+            <a:r>
+              <a:rPr sz="2200">
+                <a:solidFill>
+                  <a:srgbClr val="172033"/>
+                </a:solidFill>
+              </a:rPr>
+              <a:t>Contain, then investigate — no rollback</a:t>
+            </a:r>
+          </a:p>
+        </p:txBody>
+      </p:sp>
+      <p:sp>
+        <p:nvSpPr>
+          <p:cNvPr id="9" name="Rounded Rectangle 8"/>
+          <p:cNvSpPr/>
+          <p:nvPr/>
+        </p:nvSpPr>
+        <p:spPr>
+          <a:xfrm>
+            <a:off x="640080" y="2971800"/>
+            <a:ext cx="10881360" cy="960120"/>
+          </a:xfrm>
+          <a:prstGeom prst="roundRect">
+            <a:avLst/>
+          </a:prstGeom>
+          <a:solidFill>
+            <a:srgbClr val="FFFFFF"/>
+          </a:solidFill>
+          <a:ln>
+            <a:solidFill>
+              <a:srgbClr val="D5DEE8"/>
+            </a:solidFill>
+          </a:ln>
+        </p:spPr>
+        <p:style>
+          <a:lnRef idx="1">
+            <a:schemeClr val="accent1"/>
+          </a:lnRef>
+          <a:fillRef idx="3">
+            <a:schemeClr val="accent1"/>
+          </a:fillRef>
+          <a:effectRef idx="2">
+            <a:schemeClr val="accent1"/>
+          </a:effectRef>
+          <a:fontRef idx="minor">
+            <a:schemeClr val="lt1"/>
+          </a:fontRef>
+        </p:style>
+        <p:txBody>
+          <a:bodyPr rtlCol="0" anchor="ctr"/>
+          <a:lstStyle/>
+          <a:p>
+            <a:pPr algn="ctr"/>
+          </a:p>
+        </p:txBody>
+      </p:sp>
+      <p:sp>
+        <p:nvSpPr>
+          <p:cNvPr id="10" name="Rectangle 9"/>
+          <p:cNvSpPr/>
+          <p:nvPr/>
+        </p:nvSpPr>
+        <p:spPr>
+          <a:xfrm>
+            <a:off x="640080" y="2971800"/>
+            <a:ext cx="128016" cy="960120"/>
+          </a:xfrm>
+          <a:prstGeom prst="rect">
+            <a:avLst/>
+          </a:prstGeom>
+          <a:solidFill>
+            <a:srgbClr val="B77A1F"/>
+          </a:solidFill>
+          <a:ln>
+            <a:noFill/>
+          </a:ln>
+        </p:spPr>
+        <p:style>
+          <a:lnRef idx="1">
+            <a:schemeClr val="accent1"/>
+          </a:lnRef>
+          <a:fillRef idx="3">
+            <a:schemeClr val="accent1"/>
+          </a:fillRef>
+          <a:effectRef idx="2">
+            <a:schemeClr val="accent1"/>
+          </a:effectRef>
+          <a:fontRef idx="minor">
+            <a:schemeClr val="lt1"/>
+          </a:fontRef>
+        </p:style>
+        <p:txBody>
+          <a:bodyPr rtlCol="0" anchor="ctr"/>
+          <a:lstStyle/>
+          <a:p>
+            <a:pPr algn="ctr"/>
+          </a:p>
+        </p:txBody>
+      </p:sp>
+      <p:sp>
+        <p:nvSpPr>
+          <p:cNvPr id="11" name="TextBox 10"/>
+          <p:cNvSpPr txBox="1"/>
+          <p:nvPr/>
+        </p:nvSpPr>
+        <p:spPr>
+          <a:xfrm>
+            <a:off x="1005840" y="3081528"/>
+            <a:ext cx="2011680" cy="731520"/>
+          </a:xfrm>
+          <a:prstGeom prst="rect">
+            <a:avLst/>
+          </a:prstGeom>
+          <a:noFill/>
+        </p:spPr>
+        <p:txBody>
+          <a:bodyPr wrap="none">
+            <a:spAutoFit/>
+          </a:bodyPr>
+          <a:lstStyle/>
+          <a:p>
+            <a:r>
+              <a:rPr sz="2000" b="1">
+                <a:solidFill>
+                  <a:srgbClr val="B77A1F"/>
+                </a:solidFill>
+              </a:rPr>
+              <a:t>Plan</a:t>
+            </a:r>
+          </a:p>
+        </p:txBody>
+      </p:sp>
+      <p:sp>
+        <p:nvSpPr>
+          <p:cNvPr id="12" name="TextBox 11"/>
+          <p:cNvSpPr txBox="1"/>
+          <p:nvPr/>
+        </p:nvSpPr>
+        <p:spPr>
+          <a:xfrm>
+            <a:off x="3017520" y="3081528"/>
+            <a:ext cx="8321040" cy="731520"/>
+          </a:xfrm>
+          <a:prstGeom prst="rect">
+            <a:avLst/>
+          </a:prstGeom>
+          <a:noFill/>
+        </p:spPr>
+        <p:txBody>
+          <a:bodyPr wrap="square">
+            <a:spAutoFit/>
+          </a:bodyPr>
+          <a:lstStyle/>
+          <a:p>
+            <a:r>
+              <a:rPr sz="2200">
+                <a:solidFill>
+                  <a:srgbClr val="172033"/>
+                </a:solidFill>
+              </a:rPr>
+              <a:t>Banner → trace → audit → smallest fix → regression test</a:t>
+            </a:r>
+          </a:p>
+        </p:txBody>
+      </p:sp>
+      <p:sp>
+        <p:nvSpPr>
+          <p:cNvPr id="13" name="Rounded Rectangle 12"/>
+          <p:cNvSpPr/>
+          <p:nvPr/>
+        </p:nvSpPr>
+        <p:spPr>
+          <a:xfrm>
+            <a:off x="640080" y="4114800"/>
+            <a:ext cx="10881360" cy="960120"/>
+          </a:xfrm>
+          <a:prstGeom prst="roundRect">
+            <a:avLst/>
+          </a:prstGeom>
+          <a:solidFill>
+            <a:srgbClr val="FFFFFF"/>
+          </a:solidFill>
+          <a:ln>
+            <a:solidFill>
+              <a:srgbClr val="D5DEE8"/>
+            </a:solidFill>
+          </a:ln>
+        </p:spPr>
+        <p:style>
+          <a:lnRef idx="1">
+            <a:schemeClr val="accent1"/>
+          </a:lnRef>
+          <a:fillRef idx="3">
+            <a:schemeClr val="accent1"/>
+          </a:fillRef>
+          <a:effectRef idx="2">
+            <a:schemeClr val="accent1"/>
+          </a:effectRef>
+          <a:fontRef idx="minor">
+            <a:schemeClr val="lt1"/>
+          </a:fontRef>
+        </p:style>
+        <p:txBody>
+          <a:bodyPr rtlCol="0" anchor="ctr"/>
+          <a:lstStyle/>
+          <a:p>
+            <a:pPr algn="ctr"/>
+          </a:p>
+        </p:txBody>
+      </p:sp>
+      <p:sp>
+        <p:nvSpPr>
+          <p:cNvPr id="14" name="Rectangle 13"/>
+          <p:cNvSpPr/>
+          <p:nvPr/>
+        </p:nvSpPr>
+        <p:spPr>
+          <a:xfrm>
+            <a:off x="640080" y="4114800"/>
+            <a:ext cx="128016" cy="960120"/>
+          </a:xfrm>
+          <a:prstGeom prst="rect">
+            <a:avLst/>
+          </a:prstGeom>
+          <a:solidFill>
+            <a:srgbClr val="B77A1F"/>
+          </a:solidFill>
+          <a:ln>
+            <a:noFill/>
+          </a:ln>
+        </p:spPr>
+        <p:style>
+          <a:lnRef idx="1">
+            <a:schemeClr val="accent1"/>
+          </a:lnRef>
+          <a:fillRef idx="3">
+            <a:schemeClr val="accent1"/>
+          </a:fillRef>
+          <a:effectRef idx="2">
+            <a:schemeClr val="accent1"/>
+          </a:effectRef>
+          <a:fontRef idx="minor">
+            <a:schemeClr val="lt1"/>
+          </a:fontRef>
+        </p:style>
+        <p:txBody>
+          <a:bodyPr rtlCol="0" anchor="ctr"/>
+          <a:lstStyle/>
+          <a:p>
+            <a:pPr algn="ctr"/>
+          </a:p>
+        </p:txBody>
+      </p:sp>
+      <p:sp>
+        <p:nvSpPr>
+          <p:cNvPr id="15" name="TextBox 14"/>
+          <p:cNvSpPr txBox="1"/>
+          <p:nvPr/>
+        </p:nvSpPr>
+        <p:spPr>
+          <a:xfrm>
+            <a:off x="1005840" y="4224528"/>
+            <a:ext cx="2011680" cy="731520"/>
+          </a:xfrm>
+          <a:prstGeom prst="rect">
+            <a:avLst/>
+          </a:prstGeom>
+          <a:noFill/>
+        </p:spPr>
+        <p:txBody>
+          <a:bodyPr wrap="none">
+            <a:spAutoFit/>
+          </a:bodyPr>
+          <a:lstStyle/>
+          <a:p>
+            <a:r>
+              <a:rPr sz="2000" b="1">
+                <a:solidFill>
+                  <a:srgbClr val="B77A1F"/>
+                </a:solidFill>
+              </a:rPr>
+              <a:t>Proof</a:t>
+            </a:r>
+          </a:p>
+        </p:txBody>
+      </p:sp>
+      <p:sp>
+        <p:nvSpPr>
+          <p:cNvPr id="16" name="TextBox 15"/>
+          <p:cNvSpPr txBox="1"/>
+          <p:nvPr/>
+        </p:nvSpPr>
+        <p:spPr>
+          <a:xfrm>
+            <a:off x="3017520" y="4224528"/>
+            <a:ext cx="8321040" cy="731520"/>
+          </a:xfrm>
+          <a:prstGeom prst="rect">
+            <a:avLst/>
+          </a:prstGeom>
+          <a:noFill/>
+        </p:spPr>
+        <p:txBody>
+          <a:bodyPr wrap="square">
+            <a:spAutoFit/>
+          </a:bodyPr>
+          <a:lstStyle/>
+          <a:p>
+            <a:r>
+              <a:rPr sz="2200">
+                <a:solidFill>
+                  <a:srgbClr val="172033"/>
+                </a:solidFill>
+              </a:rPr>
+              <a:t>Original case passes; zero old-version citations</a:t>
+            </a:r>
+          </a:p>
+        </p:txBody>
+      </p:sp>
+      <p:sp>
+        <p:nvSpPr>
+          <p:cNvPr id="17" name="Rounded Rectangle 16"/>
+          <p:cNvSpPr/>
+          <p:nvPr/>
+        </p:nvSpPr>
+        <p:spPr>
+          <a:xfrm>
+            <a:off x="640080" y="5257800"/>
+            <a:ext cx="10881360" cy="960120"/>
+          </a:xfrm>
+          <a:prstGeom prst="roundRect">
+            <a:avLst/>
+          </a:prstGeom>
+          <a:solidFill>
+            <a:srgbClr val="FFFFFF"/>
+          </a:solidFill>
+          <a:ln>
+            <a:solidFill>
+              <a:srgbClr val="D5DEE8"/>
+            </a:solidFill>
+          </a:ln>
+        </p:spPr>
+        <p:style>
+          <a:lnRef idx="1">
+            <a:schemeClr val="accent1"/>
+          </a:lnRef>
+          <a:fillRef idx="3">
+            <a:schemeClr val="accent1"/>
+          </a:fillRef>
+          <a:effectRef idx="2">
+            <a:schemeClr val="accent1"/>
+          </a:effectRef>
+          <a:fontRef idx="minor">
+            <a:schemeClr val="lt1"/>
+          </a:fontRef>
+        </p:style>
+        <p:txBody>
+          <a:bodyPr rtlCol="0" anchor="ctr"/>
+          <a:lstStyle/>
+          <a:p>
+            <a:pPr algn="ctr"/>
+          </a:p>
+        </p:txBody>
+      </p:sp>
+      <p:sp>
+        <p:nvSpPr>
+          <p:cNvPr id="18" name="Rectangle 17"/>
+          <p:cNvSpPr/>
+          <p:nvPr/>
+        </p:nvSpPr>
+        <p:spPr>
+          <a:xfrm>
+            <a:off x="640080" y="5257800"/>
+            <a:ext cx="128016" cy="960120"/>
+          </a:xfrm>
+          <a:prstGeom prst="rect">
+            <a:avLst/>
+          </a:prstGeom>
+          <a:solidFill>
+            <a:srgbClr val="B77A1F"/>
+          </a:solidFill>
+          <a:ln>
+            <a:noFill/>
+          </a:ln>
+        </p:spPr>
+        <p:style>
+          <a:lnRef idx="1">
+            <a:schemeClr val="accent1"/>
+          </a:lnRef>
+          <a:fillRef idx="3">
+            <a:schemeClr val="accent1"/>
+          </a:fillRef>
+          <a:effectRef idx="2">
+            <a:schemeClr val="accent1"/>
+          </a:effectRef>
+          <a:fontRef idx="minor">
+            <a:schemeClr val="lt1"/>
+          </a:fontRef>
+        </p:style>
+        <p:txBody>
+          <a:bodyPr rtlCol="0" anchor="ctr"/>
+          <a:lstStyle/>
+          <a:p>
+            <a:pPr algn="ctr"/>
+          </a:p>
+        </p:txBody>
+      </p:sp>
+      <p:sp>
+        <p:nvSpPr>
+          <p:cNvPr id="19" name="TextBox 18"/>
+          <p:cNvSpPr txBox="1"/>
+          <p:nvPr/>
+        </p:nvSpPr>
+        <p:spPr>
+          <a:xfrm>
+            <a:off x="1005840" y="5367528"/>
+            <a:ext cx="2011680" cy="731520"/>
+          </a:xfrm>
+          <a:prstGeom prst="rect">
+            <a:avLst/>
+          </a:prstGeom>
+          <a:noFill/>
+        </p:spPr>
+        <p:txBody>
+          <a:bodyPr wrap="none">
+            <a:spAutoFit/>
+          </a:bodyPr>
+          <a:lstStyle/>
+          <a:p>
+            <a:r>
+              <a:rPr sz="2000" b="1">
+                <a:solidFill>
+                  <a:srgbClr val="B77A1F"/>
+                </a:solidFill>
+              </a:rPr>
+              <a:t>Owner</a:t>
+            </a:r>
+          </a:p>
+        </p:txBody>
+      </p:sp>
+      <p:sp>
+        <p:nvSpPr>
+          <p:cNvPr id="20" name="TextBox 19"/>
+          <p:cNvSpPr txBox="1"/>
+          <p:nvPr/>
+        </p:nvSpPr>
+        <p:spPr>
+          <a:xfrm>
+            <a:off x="3017520" y="5367528"/>
+            <a:ext cx="8321040" cy="731520"/>
+          </a:xfrm>
+          <a:prstGeom prst="rect">
+            <a:avLst/>
+          </a:prstGeom>
+          <a:noFill/>
+        </p:spPr>
+        <p:txBody>
+          <a:bodyPr wrap="square">
+            <a:spAutoFit/>
+          </a:bodyPr>
+          <a:lstStyle/>
+          <a:p>
+            <a:r>
+              <a:rPr sz="2200">
+                <a:solidFill>
+                  <a:srgbClr val="172033"/>
+                </a:solidFill>
+              </a:rPr>
+              <a:t>People Ops + AI platform lead</a:t>
             </a:r>
           </a:p>
         </p:txBody>

</xml_diff>